<commit_message>
docs(ejemplo): informes regenerados con 0.5.1, Word y el combinado carga_completa
04_hechos_ventas y job_carga_dw en los formatos de antes mas .docx; carga_completa.pdf/.docx con el job y sus cinco transformaciones (portada, indice y un capitulo por documento). Capturas del PDF, tablas del README, guion (parte 3) e informes_ejemplo.py al dia.

Co-Authored-By: Claude Opus 5.5 <noreply@anthropic.com>
</commit_message>
<xml_diff>
--- a/ejemplo/informes/job_carga_dw.pptx
+++ b/ejemplo/informes/job_carga_dw.pptx
@@ -813,7 +813,7 @@
           <a:p>
             <a:r>
               <a:rPr lang="es-ES" sz="1200"/>
-              <a:t>La última ejecución del job tardó 3,4 s y terminó bien; se ejecutaron 10 entradas. La entrada más lenta fue «Cargar dim_producto» (1,0 s).</a:t>
+              <a:t>La última ejecución del job tardó 3,2 s y terminó bien; se ejecutaron 9 entradas. La entrada más lenta fue «Cargar dim_producto» (839 ms).</a:t>
             </a:r>
           </a:p>
         </p:txBody>
@@ -4369,7 +4369,7 @@
                 </a:solidFill>
                 <a:latin typeface="Segoe UI"/>
               </a:rPr>
-              <a:t>Generado el 20 de octubre de 2026, 23:30</a:t>
+              <a:t>Generado el 21 de octubre de 2026, 16:11</a:t>
             </a:r>
             <a:endParaRPr sz="1200" lang="es-ES"/>
           </a:p>
@@ -4557,7 +4557,7 @@
           <a:lstStyle/>
           <a:p>
             <a:pPr algn="r"/>
-            <a:fld id="{CA3C9DAF-EDA8-4E66-B71F-999AD9FBBF5F}" type="slidenum">
+            <a:fld id="{066018AC-E78D-4CFE-98DC-FDD5331AE84E}" type="slidenum">
               <a:rPr lang="es-ES" sz="750">
                 <a:solidFill>
                   <a:srgbClr val="6B7785"/>
@@ -4979,7 +4979,7 @@
                           </a:solidFill>
                           <a:latin typeface="Segoe UI"/>
                         </a:rPr>
-                        <a:t>+23 ms</a:t>
+                        <a:t>+26 ms</a:t>
                       </a:r>
                       <a:endParaRPr sz="1100" lang="es-ES"/>
                     </a:p>
@@ -5021,7 +5021,7 @@
                           </a:solidFill>
                           <a:latin typeface="Segoe UI"/>
                         </a:rPr>
-                        <a:t>6 ms</a:t>
+                        <a:t>5 ms</a:t>
                       </a:r>
                       <a:endParaRPr sz="1100" lang="es-ES"/>
                     </a:p>
@@ -5233,7 +5233,7 @@
                           </a:solidFill>
                           <a:latin typeface="Segoe UI"/>
                         </a:rPr>
-                        <a:t>+30 ms</a:t>
+                        <a:t>+32 ms</a:t>
                       </a:r>
                       <a:endParaRPr sz="1100" lang="es-ES"/>
                     </a:p>
@@ -5487,7 +5487,7 @@
                           </a:solidFill>
                           <a:latin typeface="Segoe UI"/>
                         </a:rPr>
-                        <a:t>+36 ms</a:t>
+                        <a:t>+38 ms</a:t>
                       </a:r>
                       <a:endParaRPr sz="1100" lang="es-ES"/>
                     </a:p>
@@ -5741,7 +5741,7 @@
                           </a:solidFill>
                           <a:latin typeface="Segoe UI"/>
                         </a:rPr>
-                        <a:t>+38 ms</a:t>
+                        <a:t>+40 ms</a:t>
                       </a:r>
                       <a:endParaRPr sz="1100" lang="es-ES"/>
                     </a:p>
@@ -5783,7 +5783,7 @@
                           </a:solidFill>
                           <a:latin typeface="Segoe UI"/>
                         </a:rPr>
-                        <a:t>552 ms</a:t>
+                        <a:t>510 ms</a:t>
                       </a:r>
                       <a:endParaRPr sz="1100" lang="es-ES"/>
                     </a:p>
@@ -5995,7 +5995,7 @@
                           </a:solidFill>
                           <a:latin typeface="Segoe UI"/>
                         </a:rPr>
-                        <a:t>+592 ms</a:t>
+                        <a:t>+552 ms</a:t>
                       </a:r>
                       <a:endParaRPr sz="1100" lang="es-ES"/>
                     </a:p>
@@ -6037,7 +6037,7 @@
                           </a:solidFill>
                           <a:latin typeface="Segoe UI"/>
                         </a:rPr>
-                        <a:t>327 ms</a:t>
+                        <a:t>324 ms</a:t>
                       </a:r>
                       <a:endParaRPr sz="1100" lang="es-ES"/>
                     </a:p>
@@ -6249,7 +6249,7 @@
                           </a:solidFill>
                           <a:latin typeface="Segoe UI"/>
                         </a:rPr>
-                        <a:t>+920 ms</a:t>
+                        <a:t>+878 ms</a:t>
                       </a:r>
                       <a:endParaRPr sz="1100" lang="es-ES"/>
                     </a:p>
@@ -6291,7 +6291,7 @@
                           </a:solidFill>
                           <a:latin typeface="Segoe UI"/>
                         </a:rPr>
-                        <a:t>1,0 s</a:t>
+                        <a:t>839 ms</a:t>
                       </a:r>
                       <a:endParaRPr sz="1100" lang="es-ES"/>
                     </a:p>
@@ -6503,7 +6503,7 @@
                           </a:solidFill>
                           <a:latin typeface="Segoe UI"/>
                         </a:rPr>
-                        <a:t>+2,0 s</a:t>
+                        <a:t>+1,7 s</a:t>
                       </a:r>
                       <a:endParaRPr sz="1100" lang="es-ES"/>
                     </a:p>
@@ -6545,7 +6545,7 @@
                           </a:solidFill>
                           <a:latin typeface="Segoe UI"/>
                         </a:rPr>
-                        <a:t>461 ms</a:t>
+                        <a:t>449 ms</a:t>
                       </a:r>
                       <a:endParaRPr sz="1100" lang="es-ES"/>
                     </a:p>
@@ -6757,7 +6757,7 @@
                           </a:solidFill>
                           <a:latin typeface="Segoe UI"/>
                         </a:rPr>
-                        <a:t>+2,4 s</a:t>
+                        <a:t>+2,2 s</a:t>
                       </a:r>
                       <a:endParaRPr sz="1100" lang="es-ES"/>
                     </a:p>
@@ -6799,7 +6799,7 @@
                           </a:solidFill>
                           <a:latin typeface="Segoe UI"/>
                         </a:rPr>
-                        <a:t>833 ms</a:t>
+                        <a:t>831 ms</a:t>
                       </a:r>
                       <a:endParaRPr sz="1100" lang="es-ES"/>
                     </a:p>
@@ -7011,7 +7011,7 @@
                           </a:solidFill>
                           <a:latin typeface="Segoe UI"/>
                         </a:rPr>
-                        <a:t>+3,3 s</a:t>
+                        <a:t>+3,0 s</a:t>
                       </a:r>
                       <a:endParaRPr sz="1100" lang="es-ES"/>
                     </a:p>
@@ -7053,7 +7053,7 @@
                           </a:solidFill>
                           <a:latin typeface="Segoe UI"/>
                         </a:rPr>
-                        <a:t>142 ms</a:t>
+                        <a:t>155 ms</a:t>
                       </a:r>
                       <a:endParaRPr sz="1100" lang="es-ES"/>
                     </a:p>
@@ -7265,7 +7265,7 @@
                           </a:solidFill>
                           <a:latin typeface="Segoe UI"/>
                         </a:rPr>
-                        <a:t>+3,4 s</a:t>
+                        <a:t>+3,2 s</a:t>
                       </a:r>
                       <a:endParaRPr sz="1100" lang="es-ES"/>
                     </a:p>
@@ -7607,7 +7607,7 @@
           <a:lstStyle/>
           <a:p>
             <a:pPr algn="r"/>
-            <a:fld id="{44529BD9-8FDD-434B-8266-B475D871B357}" type="slidenum">
+            <a:fld id="{E6F81376-BCD1-44DF-83DB-F798CF073D71}" type="slidenum">
               <a:rPr lang="es-ES" sz="750">
                 <a:solidFill>
                   <a:srgbClr val="6B7785"/>
@@ -8300,7 +8300,7 @@
           <a:lstStyle/>
           <a:p>
             <a:pPr algn="r"/>
-            <a:fld id="{2F8613A4-CD8D-41A3-8A96-74B711B2C4E5}" type="slidenum">
+            <a:fld id="{126994DA-6263-4067-A5E1-C9C035E56422}" type="slidenum">
               <a:rPr lang="es-ES" sz="750">
                 <a:solidFill>
                   <a:srgbClr val="6B7785"/>
@@ -9097,7 +9097,7 @@
           <a:lstStyle/>
           <a:p>
             <a:pPr algn="r"/>
-            <a:fld id="{2FCBCF1D-379D-4F82-9EB1-B32A9675FFF2}" type="slidenum">
+            <a:fld id="{97B6DDC8-F00F-4C67-9AEF-3B233204A57A}" type="slidenum">
               <a:rPr lang="es-ES" sz="750">
                 <a:solidFill>
                   <a:srgbClr val="6B7785"/>
@@ -9507,7 +9507,7 @@
           <a:lstStyle/>
           <a:p>
             <a:pPr algn="r"/>
-            <a:fld id="{22F4C4DA-0DD3-4755-87BB-2F897D50EFB1}" type="slidenum">
+            <a:fld id="{0DFFC700-8A54-4066-B7D9-170CE7C47ABA}" type="slidenum">
               <a:rPr lang="es-ES" sz="750">
                 <a:solidFill>
                   <a:srgbClr val="6B7785"/>
@@ -10111,7 +10111,7 @@
                 </a:solidFill>
                 <a:latin typeface="Segoe UI"/>
               </a:rPr>
-              <a:t>La última ejecución del job tardó 3,4 s y terminó bien; se ejecutaron 10 entradas. La entrada más lenta fue «Cargar dim_producto» (1,0 s).</a:t>
+              <a:t>La última ejecución del job tardó 3,2 s y terminó bien; se ejecutaron 9 entradas. La entrada más lenta fue «Cargar dim_producto» (839 ms).</a:t>
             </a:r>
             <a:endParaRPr sz="1400" lang="es-ES"/>
           </a:p>
@@ -10299,7 +10299,7 @@
           <a:lstStyle/>
           <a:p>
             <a:pPr algn="r"/>
-            <a:fld id="{83896471-2A17-47A1-B2F0-A1DA0BBDE264}" type="slidenum">
+            <a:fld id="{3621EFD7-B0AE-467F-B8F2-232E231B63A8}" type="slidenum">
               <a:rPr lang="es-ES" sz="750">
                 <a:solidFill>
                   <a:srgbClr val="6B7785"/>
@@ -10640,7 +10640,7 @@
           <a:lstStyle/>
           <a:p>
             <a:pPr algn="r"/>
-            <a:fld id="{9902BDA6-C4DC-4097-9FEB-61C37883B39E}" type="slidenum">
+            <a:fld id="{22F68A5F-9720-4E2B-90A6-BC37E4AB1AFA}" type="slidenum">
               <a:rPr lang="es-ES" sz="750">
                 <a:solidFill>
                   <a:srgbClr val="6B7785"/>
@@ -10662,793 +10662,30 @@
           <p:nvPr/>
         </p:nvPicPr>
         <p:blipFill>
-          <a:blip r:embed="rId4"/>
+          <a:blip r:embed="rId4">
+            <a:extLst>
+              <a:ext uri="{28A0092B-C50C-407E-A947-70E740481C1C}">
+                <a14:useLocalDpi xmlns:a14="http://schemas.microsoft.com/office/drawing/2010/main" val="0"/>
+              </a:ext>
+              <a:ext uri="{96DAC541-7B7A-43D3-8B79-37D633B846F1}">
+                <asvg:svgBlip xmlns:asvg="http://schemas.microsoft.com/office/drawing/2016/SVG/main" r:embed="rId5"/>
+              </a:ext>
+            </a:extLst>
+          </a:blip>
           <a:stretch>
             <a:fillRect/>
           </a:stretch>
         </p:blipFill>
         <p:spPr>
           <a:xfrm>
-            <a:off x="508000" y="1016000"/>
-            <a:ext cx="11176000" cy="2997200"/>
+            <a:off x="1017814" y="1016000"/>
+            <a:ext cx="10156371" cy="5257800"/>
           </a:xfrm>
           <a:prstGeom prst="rect">
             <a:avLst/>
           </a:prstGeom>
         </p:spPr>
       </p:pic>
-      <p:sp>
-        <p:nvSpPr>
-          <p:cNvPr name="TextBox 9" id="9"/>
-          <p:cNvSpPr txBox="true"/>
-          <p:nvPr/>
-        </p:nvSpPr>
-        <p:spPr>
-          <a:xfrm>
-            <a:off x="508000" y="4064000"/>
-            <a:ext cx="11176000" cy="235458"/>
-          </a:xfrm>
-          <a:prstGeom prst="rect">
-            <a:avLst/>
-          </a:prstGeom>
-        </p:spPr>
-        <p:txBody>
-          <a:bodyPr anchor="t" rtlCol="false" wrap="square" lIns="0" rIns="0" tIns="25400" bIns="25400"/>
-          <a:lstStyle/>
-          <a:p>
-            <a:pPr algn="l"/>
-            <a:r>
-              <a:rPr lang="es-ES" sz="950" b="false" i="true">
-                <a:solidFill>
-                  <a:srgbClr val="6B7785"/>
-                </a:solidFill>
-                <a:latin typeface="Segoe UI"/>
-              </a:rPr>
-              <a:t>Verde: si termina bien; rojo punteado: si falla; negro: siempre; las que terminan en x están deshabilitadas.</a:t>
-            </a:r>
-            <a:endParaRPr sz="950" lang="es-ES"/>
-          </a:p>
-        </p:txBody>
-      </p:sp>
-      <p:sp>
-        <p:nvSpPr>
-          <p:cNvPr name="TextBox 10" id="10"/>
-          <p:cNvSpPr txBox="true"/>
-          <p:nvPr/>
-        </p:nvSpPr>
-        <p:spPr>
-          <a:xfrm>
-            <a:off x="508000" y="4426458"/>
-            <a:ext cx="11176000" cy="254000"/>
-          </a:xfrm>
-          <a:prstGeom prst="rect">
-            <a:avLst/>
-          </a:prstGeom>
-        </p:spPr>
-        <p:txBody>
-          <a:bodyPr anchor="t" rtlCol="false" wrap="square" lIns="0" rIns="0" tIns="25400" bIns="25400"/>
-          <a:lstStyle/>
-          <a:p>
-            <a:pPr algn="l"/>
-            <a:r>
-              <a:rPr lang="es-ES" sz="1300" b="true" i="false">
-                <a:solidFill>
-                  <a:srgbClr val="243B53"/>
-                </a:solidFill>
-                <a:latin typeface="Segoe UI"/>
-              </a:rPr>
-              <a:t>Entradas del job</a:t>
-            </a:r>
-            <a:endParaRPr sz="1300" lang="es-ES"/>
-          </a:p>
-        </p:txBody>
-      </p:sp>
-      <p:graphicFrame>
-        <p:nvGraphicFramePr>
-          <p:cNvPr name="Table 11" id="11"/>
-          <p:cNvGraphicFramePr>
-            <a:graphicFrameLocks noGrp="true"/>
-          </p:cNvGraphicFramePr>
-          <p:nvPr/>
-        </p:nvGraphicFramePr>
-        <p:xfrm>
-          <a:off x="508000" y="4705858"/>
-          <a:ext cx="9448800" cy="1194816"/>
-        </p:xfrm>
-        <a:graphic>
-          <a:graphicData uri="http://schemas.openxmlformats.org/drawingml/2006/table">
-            <a:tbl>
-              <a:tblPr/>
-              <a:tblGrid>
-                <a:gridCol w="406400"/>
-                <a:gridCol w="2400300"/>
-                <a:gridCol w="2781300"/>
-                <a:gridCol w="3860800"/>
-              </a:tblGrid>
-              <a:tr h="298704">
-                <a:tc>
-                  <a:txBody>
-                    <a:bodyPr anchor="t" rtlCol="false"/>
-                    <a:lstStyle/>
-                    <a:p>
-                      <a:pPr algn="r"/>
-                      <a:r>
-                        <a:rPr lang="es-ES" sz="1100" b="true" i="false">
-                          <a:solidFill>
-                            <a:srgbClr val="FFFFFF"/>
-                          </a:solidFill>
-                          <a:latin typeface="Segoe UI"/>
-                        </a:rPr>
-                        <a:t>#</a:t>
-                      </a:r>
-                      <a:endParaRPr sz="1100" lang="es-ES"/>
-                    </a:p>
-                  </a:txBody>
-                  <a:tcPr marL="76200" marR="76200" marT="38100" marB="38100" anchor="ctr">
-                    <a:lnL>
-                      <a:noFill/>
-                    </a:lnL>
-                    <a:lnR>
-                      <a:noFill/>
-                    </a:lnR>
-                    <a:lnT>
-                      <a:noFill/>
-                    </a:lnT>
-                    <a:lnB cmpd="sng" algn="ctr" cap="flat" w="9525">
-                      <a:solidFill>
-                        <a:srgbClr val="243B53"/>
-                      </a:solidFill>
-                      <a:prstDash val="solid"/>
-                      <a:round/>
-                      <a:headEnd type="none" w="med" len="med"/>
-                      <a:tailEnd type="none" w="med" len="med"/>
-                    </a:lnB>
-                    <a:solidFill>
-                      <a:srgbClr val="243B53"/>
-                    </a:solidFill>
-                  </a:tcPr>
-                </a:tc>
-                <a:tc>
-                  <a:txBody>
-                    <a:bodyPr anchor="t" rtlCol="false"/>
-                    <a:lstStyle/>
-                    <a:p>
-                      <a:pPr algn="l"/>
-                      <a:r>
-                        <a:rPr lang="es-ES" sz="1100" b="true" i="false">
-                          <a:solidFill>
-                            <a:srgbClr val="FFFFFF"/>
-                          </a:solidFill>
-                          <a:latin typeface="Segoe UI"/>
-                        </a:rPr>
-                        <a:t>Entrada</a:t>
-                      </a:r>
-                      <a:endParaRPr sz="1100" lang="es-ES"/>
-                    </a:p>
-                  </a:txBody>
-                  <a:tcPr marL="76200" marR="76200" marT="38100" marB="38100" anchor="ctr">
-                    <a:lnL>
-                      <a:noFill/>
-                    </a:lnL>
-                    <a:lnR>
-                      <a:noFill/>
-                    </a:lnR>
-                    <a:lnT>
-                      <a:noFill/>
-                    </a:lnT>
-                    <a:lnB cmpd="sng" algn="ctr" cap="flat" w="9525">
-                      <a:solidFill>
-                        <a:srgbClr val="243B53"/>
-                      </a:solidFill>
-                      <a:prstDash val="solid"/>
-                      <a:round/>
-                      <a:headEnd type="none" w="med" len="med"/>
-                      <a:tailEnd type="none" w="med" len="med"/>
-                    </a:lnB>
-                    <a:solidFill>
-                      <a:srgbClr val="243B53"/>
-                    </a:solidFill>
-                  </a:tcPr>
-                </a:tc>
-                <a:tc>
-                  <a:txBody>
-                    <a:bodyPr anchor="t" rtlCol="false"/>
-                    <a:lstStyle/>
-                    <a:p>
-                      <a:pPr algn="l"/>
-                      <a:r>
-                        <a:rPr lang="es-ES" sz="1100" b="true" i="false">
-                          <a:solidFill>
-                            <a:srgbClr val="FFFFFF"/>
-                          </a:solidFill>
-                          <a:latin typeface="Segoe UI"/>
-                        </a:rPr>
-                        <a:t>Tipo</a:t>
-                      </a:r>
-                      <a:endParaRPr sz="1100" lang="es-ES"/>
-                    </a:p>
-                  </a:txBody>
-                  <a:tcPr marL="76200" marR="76200" marT="38100" marB="38100" anchor="ctr">
-                    <a:lnL>
-                      <a:noFill/>
-                    </a:lnL>
-                    <a:lnR>
-                      <a:noFill/>
-                    </a:lnR>
-                    <a:lnT>
-                      <a:noFill/>
-                    </a:lnT>
-                    <a:lnB cmpd="sng" algn="ctr" cap="flat" w="9525">
-                      <a:solidFill>
-                        <a:srgbClr val="243B53"/>
-                      </a:solidFill>
-                      <a:prstDash val="solid"/>
-                      <a:round/>
-                      <a:headEnd type="none" w="med" len="med"/>
-                      <a:tailEnd type="none" w="med" len="med"/>
-                    </a:lnB>
-                    <a:solidFill>
-                      <a:srgbClr val="243B53"/>
-                    </a:solidFill>
-                  </a:tcPr>
-                </a:tc>
-                <a:tc>
-                  <a:txBody>
-                    <a:bodyPr anchor="t" rtlCol="false"/>
-                    <a:lstStyle/>
-                    <a:p>
-                      <a:pPr algn="l"/>
-                      <a:r>
-                        <a:rPr lang="es-ES" sz="1100" b="true" i="false">
-                          <a:solidFill>
-                            <a:srgbClr val="FFFFFF"/>
-                          </a:solidFill>
-                          <a:latin typeface="Segoe UI"/>
-                        </a:rPr>
-                        <a:t>Qué hace</a:t>
-                      </a:r>
-                      <a:endParaRPr sz="1100" lang="es-ES"/>
-                    </a:p>
-                  </a:txBody>
-                  <a:tcPr marL="76200" marR="76200" marT="38100" marB="38100" anchor="ctr">
-                    <a:lnL>
-                      <a:noFill/>
-                    </a:lnL>
-                    <a:lnR>
-                      <a:noFill/>
-                    </a:lnR>
-                    <a:lnT>
-                      <a:noFill/>
-                    </a:lnT>
-                    <a:lnB cmpd="sng" algn="ctr" cap="flat" w="9525">
-                      <a:solidFill>
-                        <a:srgbClr val="243B53"/>
-                      </a:solidFill>
-                      <a:prstDash val="solid"/>
-                      <a:round/>
-                      <a:headEnd type="none" w="med" len="med"/>
-                      <a:tailEnd type="none" w="med" len="med"/>
-                    </a:lnB>
-                    <a:solidFill>
-                      <a:srgbClr val="243B53"/>
-                    </a:solidFill>
-                  </a:tcPr>
-                </a:tc>
-              </a:tr>
-              <a:tr h="298704">
-                <a:tc>
-                  <a:txBody>
-                    <a:bodyPr anchor="t" rtlCol="false"/>
-                    <a:lstStyle/>
-                    <a:p>
-                      <a:pPr algn="r"/>
-                      <a:r>
-                        <a:rPr lang="es-ES" sz="1100" b="false" i="false">
-                          <a:solidFill>
-                            <a:srgbClr val="1F2933"/>
-                          </a:solidFill>
-                          <a:latin typeface="Segoe UI"/>
-                        </a:rPr>
-                        <a:t>1</a:t>
-                      </a:r>
-                      <a:endParaRPr sz="1100" lang="es-ES"/>
-                    </a:p>
-                  </a:txBody>
-                  <a:tcPr marL="76200" marR="76200" marT="38100" marB="38100" anchor="ctr">
-                    <a:lnL>
-                      <a:noFill/>
-                    </a:lnL>
-                    <a:lnR>
-                      <a:noFill/>
-                    </a:lnR>
-                    <a:lnT>
-                      <a:noFill/>
-                    </a:lnT>
-                    <a:lnB cmpd="sng" algn="ctr" cap="flat" w="9525">
-                      <a:solidFill>
-                        <a:srgbClr val="D9DEE5"/>
-                      </a:solidFill>
-                      <a:prstDash val="solid"/>
-                      <a:round/>
-                      <a:headEnd type="none" w="med" len="med"/>
-                      <a:tailEnd type="none" w="med" len="med"/>
-                    </a:lnB>
-                    <a:solidFill>
-                      <a:srgbClr val="FFFFFF"/>
-                    </a:solidFill>
-                  </a:tcPr>
-                </a:tc>
-                <a:tc>
-                  <a:txBody>
-                    <a:bodyPr anchor="t" rtlCol="false"/>
-                    <a:lstStyle/>
-                    <a:p>
-                      <a:pPr algn="l"/>
-                      <a:r>
-                        <a:rPr lang="es-ES" sz="1100" b="false" i="false">
-                          <a:solidFill>
-                            <a:srgbClr val="1F2933"/>
-                          </a:solidFill>
-                          <a:latin typeface="Segoe UI"/>
-                        </a:rPr>
-                        <a:t>START</a:t>
-                      </a:r>
-                      <a:endParaRPr sz="1100" lang="es-ES"/>
-                    </a:p>
-                  </a:txBody>
-                  <a:tcPr marL="76200" marR="76200" marT="38100" marB="38100" anchor="ctr">
-                    <a:lnL>
-                      <a:noFill/>
-                    </a:lnL>
-                    <a:lnR>
-                      <a:noFill/>
-                    </a:lnR>
-                    <a:lnT>
-                      <a:noFill/>
-                    </a:lnT>
-                    <a:lnB cmpd="sng" algn="ctr" cap="flat" w="9525">
-                      <a:solidFill>
-                        <a:srgbClr val="D9DEE5"/>
-                      </a:solidFill>
-                      <a:prstDash val="solid"/>
-                      <a:round/>
-                      <a:headEnd type="none" w="med" len="med"/>
-                      <a:tailEnd type="none" w="med" len="med"/>
-                    </a:lnB>
-                    <a:solidFill>
-                      <a:srgbClr val="FFFFFF"/>
-                    </a:solidFill>
-                  </a:tcPr>
-                </a:tc>
-                <a:tc>
-                  <a:txBody>
-                    <a:bodyPr anchor="t" rtlCol="false"/>
-                    <a:lstStyle/>
-                    <a:p>
-                      <a:pPr algn="l"/>
-                      <a:r>
-                        <a:rPr lang="es-ES" sz="1100" b="false" i="false">
-                          <a:solidFill>
-                            <a:srgbClr val="1F2933"/>
-                          </a:solidFill>
-                          <a:latin typeface="Segoe UI"/>
-                        </a:rPr>
-                        <a:t>Inicio (SPECIAL)</a:t>
-                      </a:r>
-                      <a:endParaRPr sz="1100" lang="es-ES"/>
-                    </a:p>
-                  </a:txBody>
-                  <a:tcPr marL="76200" marR="76200" marT="38100" marB="38100" anchor="ctr">
-                    <a:lnL>
-                      <a:noFill/>
-                    </a:lnL>
-                    <a:lnR>
-                      <a:noFill/>
-                    </a:lnR>
-                    <a:lnT>
-                      <a:noFill/>
-                    </a:lnT>
-                    <a:lnB cmpd="sng" algn="ctr" cap="flat" w="9525">
-                      <a:solidFill>
-                        <a:srgbClr val="D9DEE5"/>
-                      </a:solidFill>
-                      <a:prstDash val="solid"/>
-                      <a:round/>
-                      <a:headEnd type="none" w="med" len="med"/>
-                      <a:tailEnd type="none" w="med" len="med"/>
-                    </a:lnB>
-                    <a:solidFill>
-                      <a:srgbClr val="FFFFFF"/>
-                    </a:solidFill>
-                  </a:tcPr>
-                </a:tc>
-                <a:tc>
-                  <a:txBody>
-                    <a:bodyPr anchor="t" rtlCol="false"/>
-                    <a:lstStyle/>
-                    <a:p>
-                      <a:pPr algn="l"/>
-                      <a:r>
-                        <a:rPr lang="es-ES" sz="1100" b="false" i="false">
-                          <a:solidFill>
-                            <a:srgbClr val="1F2933"/>
-                          </a:solidFill>
-                          <a:latin typeface="Segoe UI"/>
-                        </a:rPr>
-                        <a:t>Inicio del job</a:t>
-                      </a:r>
-                      <a:endParaRPr sz="1100" lang="es-ES"/>
-                    </a:p>
-                  </a:txBody>
-                  <a:tcPr marL="76200" marR="76200" marT="38100" marB="38100" anchor="ctr">
-                    <a:lnL>
-                      <a:noFill/>
-                    </a:lnL>
-                    <a:lnR>
-                      <a:noFill/>
-                    </a:lnR>
-                    <a:lnT>
-                      <a:noFill/>
-                    </a:lnT>
-                    <a:lnB cmpd="sng" algn="ctr" cap="flat" w="9525">
-                      <a:solidFill>
-                        <a:srgbClr val="D9DEE5"/>
-                      </a:solidFill>
-                      <a:prstDash val="solid"/>
-                      <a:round/>
-                      <a:headEnd type="none" w="med" len="med"/>
-                      <a:tailEnd type="none" w="med" len="med"/>
-                    </a:lnB>
-                    <a:solidFill>
-                      <a:srgbClr val="FFFFFF"/>
-                    </a:solidFill>
-                  </a:tcPr>
-                </a:tc>
-              </a:tr>
-              <a:tr h="298704">
-                <a:tc>
-                  <a:txBody>
-                    <a:bodyPr anchor="t" rtlCol="false"/>
-                    <a:lstStyle/>
-                    <a:p>
-                      <a:pPr algn="r"/>
-                      <a:r>
-                        <a:rPr lang="es-ES" sz="1100" b="false" i="false">
-                          <a:solidFill>
-                            <a:srgbClr val="1F2933"/>
-                          </a:solidFill>
-                          <a:latin typeface="Segoe UI"/>
-                        </a:rPr>
-                        <a:t>2</a:t>
-                      </a:r>
-                      <a:endParaRPr sz="1100" lang="es-ES"/>
-                    </a:p>
-                  </a:txBody>
-                  <a:tcPr marL="76200" marR="76200" marT="38100" marB="38100" anchor="ctr">
-                    <a:lnL>
-                      <a:noFill/>
-                    </a:lnL>
-                    <a:lnR>
-                      <a:noFill/>
-                    </a:lnR>
-                    <a:lnT>
-                      <a:noFill/>
-                    </a:lnT>
-                    <a:lnB cmpd="sng" algn="ctr" cap="flat" w="9525">
-                      <a:solidFill>
-                        <a:srgbClr val="D9DEE5"/>
-                      </a:solidFill>
-                      <a:prstDash val="solid"/>
-                      <a:round/>
-                      <a:headEnd type="none" w="med" len="med"/>
-                      <a:tailEnd type="none" w="med" len="med"/>
-                    </a:lnB>
-                    <a:solidFill>
-                      <a:srgbClr val="F0F1F3"/>
-                    </a:solidFill>
-                  </a:tcPr>
-                </a:tc>
-                <a:tc>
-                  <a:txBody>
-                    <a:bodyPr anchor="t" rtlCol="false"/>
-                    <a:lstStyle/>
-                    <a:p>
-                      <a:pPr algn="l"/>
-                      <a:r>
-                        <a:rPr lang="es-ES" sz="1100" b="false" i="false">
-                          <a:solidFill>
-                            <a:srgbClr val="1F2933"/>
-                          </a:solidFill>
-                          <a:latin typeface="Segoe UI"/>
-                        </a:rPr>
-                        <a:t>Comprobar ficheros de entrada</a:t>
-                      </a:r>
-                      <a:endParaRPr sz="1100" lang="es-ES"/>
-                    </a:p>
-                  </a:txBody>
-                  <a:tcPr marL="76200" marR="76200" marT="38100" marB="38100" anchor="ctr">
-                    <a:lnL>
-                      <a:noFill/>
-                    </a:lnL>
-                    <a:lnR>
-                      <a:noFill/>
-                    </a:lnR>
-                    <a:lnT>
-                      <a:noFill/>
-                    </a:lnT>
-                    <a:lnB cmpd="sng" algn="ctr" cap="flat" w="9525">
-                      <a:solidFill>
-                        <a:srgbClr val="D9DEE5"/>
-                      </a:solidFill>
-                      <a:prstDash val="solid"/>
-                      <a:round/>
-                      <a:headEnd type="none" w="med" len="med"/>
-                      <a:tailEnd type="none" w="med" len="med"/>
-                    </a:lnB>
-                    <a:solidFill>
-                      <a:srgbClr val="F0F1F3"/>
-                    </a:solidFill>
-                  </a:tcPr>
-                </a:tc>
-                <a:tc>
-                  <a:txBody>
-                    <a:bodyPr anchor="t" rtlCol="false"/>
-                    <a:lstStyle/>
-                    <a:p>
-                      <a:pPr algn="l"/>
-                      <a:r>
-                        <a:rPr lang="es-ES" sz="1100" b="false" i="false">
-                          <a:solidFill>
-                            <a:srgbClr val="1F2933"/>
-                          </a:solidFill>
-                          <a:latin typeface="Segoe UI"/>
-                        </a:rPr>
-                        <a:t>Los archivos existen (FILES_EXIST)</a:t>
-                      </a:r>
-                      <a:endParaRPr sz="1100" lang="es-ES"/>
-                    </a:p>
-                  </a:txBody>
-                  <a:tcPr marL="76200" marR="76200" marT="38100" marB="38100" anchor="ctr">
-                    <a:lnL>
-                      <a:noFill/>
-                    </a:lnL>
-                    <a:lnR>
-                      <a:noFill/>
-                    </a:lnR>
-                    <a:lnT>
-                      <a:noFill/>
-                    </a:lnT>
-                    <a:lnB cmpd="sng" algn="ctr" cap="flat" w="9525">
-                      <a:solidFill>
-                        <a:srgbClr val="D9DEE5"/>
-                      </a:solidFill>
-                      <a:prstDash val="solid"/>
-                      <a:round/>
-                      <a:headEnd type="none" w="med" len="med"/>
-                      <a:tailEnd type="none" w="med" len="med"/>
-                    </a:lnB>
-                    <a:solidFill>
-                      <a:srgbClr val="F0F1F3"/>
-                    </a:solidFill>
-                  </a:tcPr>
-                </a:tc>
-                <a:tc>
-                  <a:txBody>
-                    <a:bodyPr anchor="t" rtlCol="false"/>
-                    <a:lstStyle/>
-                    <a:p>
-                      <a:pPr algn="l"/>
-                      <a:r>
-                        <a:rPr lang="es-ES" sz="1100" b="false" i="false">
-                          <a:solidFill>
-                            <a:srgbClr val="1F2933"/>
-                          </a:solidFill>
-                          <a:latin typeface="Segoe UI"/>
-                        </a:rPr>
-                        <a:t>Los archivos existen</a:t>
-                      </a:r>
-                      <a:endParaRPr sz="1100" lang="es-ES"/>
-                    </a:p>
-                  </a:txBody>
-                  <a:tcPr marL="76200" marR="76200" marT="38100" marB="38100" anchor="ctr">
-                    <a:lnL>
-                      <a:noFill/>
-                    </a:lnL>
-                    <a:lnR>
-                      <a:noFill/>
-                    </a:lnR>
-                    <a:lnT>
-                      <a:noFill/>
-                    </a:lnT>
-                    <a:lnB cmpd="sng" algn="ctr" cap="flat" w="9525">
-                      <a:solidFill>
-                        <a:srgbClr val="D9DEE5"/>
-                      </a:solidFill>
-                      <a:prstDash val="solid"/>
-                      <a:round/>
-                      <a:headEnd type="none" w="med" len="med"/>
-                      <a:tailEnd type="none" w="med" len="med"/>
-                    </a:lnB>
-                    <a:solidFill>
-                      <a:srgbClr val="F0F1F3"/>
-                    </a:solidFill>
-                  </a:tcPr>
-                </a:tc>
-              </a:tr>
-              <a:tr h="298704">
-                <a:tc>
-                  <a:txBody>
-                    <a:bodyPr anchor="t" rtlCol="false"/>
-                    <a:lstStyle/>
-                    <a:p>
-                      <a:pPr algn="r"/>
-                      <a:r>
-                        <a:rPr lang="es-ES" sz="1100" b="false" i="false">
-                          <a:solidFill>
-                            <a:srgbClr val="1F2933"/>
-                          </a:solidFill>
-                          <a:latin typeface="Segoe UI"/>
-                        </a:rPr>
-                        <a:t>3</a:t>
-                      </a:r>
-                      <a:endParaRPr sz="1100" lang="es-ES"/>
-                    </a:p>
-                  </a:txBody>
-                  <a:tcPr marL="76200" marR="76200" marT="38100" marB="38100" anchor="ctr">
-                    <a:lnL>
-                      <a:noFill/>
-                    </a:lnL>
-                    <a:lnR>
-                      <a:noFill/>
-                    </a:lnR>
-                    <a:lnT>
-                      <a:noFill/>
-                    </a:lnT>
-                    <a:lnB cmpd="sng" algn="ctr" cap="flat" w="9525">
-                      <a:solidFill>
-                        <a:srgbClr val="D9DEE5"/>
-                      </a:solidFill>
-                      <a:prstDash val="solid"/>
-                      <a:round/>
-                      <a:headEnd type="none" w="med" len="med"/>
-                      <a:tailEnd type="none" w="med" len="med"/>
-                    </a:lnB>
-                    <a:solidFill>
-                      <a:srgbClr val="FFFFFF"/>
-                    </a:solidFill>
-                  </a:tcPr>
-                </a:tc>
-                <a:tc>
-                  <a:txBody>
-                    <a:bodyPr anchor="t" rtlCol="false"/>
-                    <a:lstStyle/>
-                    <a:p>
-                      <a:pPr algn="l"/>
-                      <a:r>
-                        <a:rPr lang="es-ES" sz="1100" b="false" i="false">
-                          <a:solidFill>
-                            <a:srgbClr val="1F2933"/>
-                          </a:solidFill>
-                          <a:latin typeface="Segoe UI"/>
-                        </a:rPr>
-                        <a:t>Crear carpeta salida</a:t>
-                      </a:r>
-                      <a:endParaRPr sz="1100" lang="es-ES"/>
-                    </a:p>
-                  </a:txBody>
-                  <a:tcPr marL="76200" marR="76200" marT="38100" marB="38100" anchor="ctr">
-                    <a:lnL>
-                      <a:noFill/>
-                    </a:lnL>
-                    <a:lnR>
-                      <a:noFill/>
-                    </a:lnR>
-                    <a:lnT>
-                      <a:noFill/>
-                    </a:lnT>
-                    <a:lnB cmpd="sng" algn="ctr" cap="flat" w="9525">
-                      <a:solidFill>
-                        <a:srgbClr val="D9DEE5"/>
-                      </a:solidFill>
-                      <a:prstDash val="solid"/>
-                      <a:round/>
-                      <a:headEnd type="none" w="med" len="med"/>
-                      <a:tailEnd type="none" w="med" len="med"/>
-                    </a:lnB>
-                    <a:solidFill>
-                      <a:srgbClr val="FFFFFF"/>
-                    </a:solidFill>
-                  </a:tcPr>
-                </a:tc>
-                <a:tc>
-                  <a:txBody>
-                    <a:bodyPr anchor="t" rtlCol="false"/>
-                    <a:lstStyle/>
-                    <a:p>
-                      <a:pPr algn="l"/>
-                      <a:r>
-                        <a:rPr lang="es-ES" sz="1100" b="false" i="false">
-                          <a:solidFill>
-                            <a:srgbClr val="1F2933"/>
-                          </a:solidFill>
-                          <a:latin typeface="Segoe UI"/>
-                        </a:rPr>
-                        <a:t>Crear carpeta (CREATE_FOLDER)</a:t>
-                      </a:r>
-                      <a:endParaRPr sz="1100" lang="es-ES"/>
-                    </a:p>
-                  </a:txBody>
-                  <a:tcPr marL="76200" marR="76200" marT="38100" marB="38100" anchor="ctr">
-                    <a:lnL>
-                      <a:noFill/>
-                    </a:lnL>
-                    <a:lnR>
-                      <a:noFill/>
-                    </a:lnR>
-                    <a:lnT>
-                      <a:noFill/>
-                    </a:lnT>
-                    <a:lnB cmpd="sng" algn="ctr" cap="flat" w="9525">
-                      <a:solidFill>
-                        <a:srgbClr val="D9DEE5"/>
-                      </a:solidFill>
-                      <a:prstDash val="solid"/>
-                      <a:round/>
-                      <a:headEnd type="none" w="med" len="med"/>
-                      <a:tailEnd type="none" w="med" len="med"/>
-                    </a:lnB>
-                    <a:solidFill>
-                      <a:srgbClr val="FFFFFF"/>
-                    </a:solidFill>
-                  </a:tcPr>
-                </a:tc>
-                <a:tc>
-                  <a:txBody>
-                    <a:bodyPr anchor="t" rtlCol="false"/>
-                    <a:lstStyle/>
-                    <a:p>
-                      <a:pPr algn="l"/>
-                      <a:r>
-                        <a:rPr lang="es-ES" sz="1100" b="false" i="false">
-                          <a:solidFill>
-                            <a:srgbClr val="1F2933"/>
-                          </a:solidFill>
-                          <a:latin typeface="Segoe UI"/>
-                        </a:rPr>
-                        <a:t>Crear carpeta</a:t>
-                      </a:r>
-                      <a:endParaRPr sz="1100" lang="es-ES"/>
-                    </a:p>
-                  </a:txBody>
-                  <a:tcPr marL="76200" marR="76200" marT="38100" marB="38100" anchor="ctr">
-                    <a:lnL>
-                      <a:noFill/>
-                    </a:lnL>
-                    <a:lnR>
-                      <a:noFill/>
-                    </a:lnR>
-                    <a:lnT>
-                      <a:noFill/>
-                    </a:lnT>
-                    <a:lnB cmpd="sng" algn="ctr" cap="flat" w="9525">
-                      <a:solidFill>
-                        <a:srgbClr val="D9DEE5"/>
-                      </a:solidFill>
-                      <a:prstDash val="solid"/>
-                      <a:round/>
-                      <a:headEnd type="none" w="med" len="med"/>
-                      <a:tailEnd type="none" w="med" len="med"/>
-                    </a:lnB>
-                    <a:solidFill>
-                      <a:srgbClr val="FFFFFF"/>
-                    </a:solidFill>
-                  </a:tcPr>
-                </a:tc>
-              </a:tr>
-            </a:tbl>
-          </a:graphicData>
-        </a:graphic>
-      </p:graphicFrame>
     </p:spTree>
   </p:cSld>
   <p:clrMapOvr>
@@ -11631,7 +10868,7 @@
           <a:lstStyle/>
           <a:p>
             <a:pPr algn="r"/>
-            <a:fld id="{A83A0C94-F6B3-4FA5-B59D-0BA7C35BA258}" type="slidenum">
+            <a:fld id="{43CBDB3C-FDAF-4358-B78F-A0647E6B93A5}" type="slidenum">
               <a:rPr lang="es-ES" sz="750">
                 <a:solidFill>
                   <a:srgbClr val="6B7785"/>
@@ -11653,6 +10890,39 @@
         <p:spPr>
           <a:xfrm>
             <a:off x="508000" y="1016000"/>
+            <a:ext cx="11176000" cy="235458"/>
+          </a:xfrm>
+          <a:prstGeom prst="rect">
+            <a:avLst/>
+          </a:prstGeom>
+        </p:spPr>
+        <p:txBody>
+          <a:bodyPr anchor="t" rtlCol="false" wrap="square" lIns="0" rIns="0" tIns="25400" bIns="25400"/>
+          <a:lstStyle/>
+          <a:p>
+            <a:pPr algn="l"/>
+            <a:r>
+              <a:rPr lang="es-ES" sz="950" b="false" i="true">
+                <a:solidFill>
+                  <a:srgbClr val="6B7785"/>
+                </a:solidFill>
+                <a:latin typeface="Segoe UI"/>
+              </a:rPr>
+              <a:t>Verde: si termina bien; rojo punteado: si falla; negro: siempre; las que terminan en x están deshabilitadas.</a:t>
+            </a:r>
+            <a:endParaRPr sz="950" lang="es-ES"/>
+          </a:p>
+        </p:txBody>
+      </p:sp>
+      <p:sp>
+        <p:nvSpPr>
+          <p:cNvPr name="TextBox 9" id="9"/>
+          <p:cNvSpPr txBox="true"/>
+          <p:nvPr/>
+        </p:nvSpPr>
+        <p:spPr>
+          <a:xfrm>
+            <a:off x="508000" y="1378458"/>
             <a:ext cx="11176000" cy="254000"/>
           </a:xfrm>
           <a:prstGeom prst="rect">
@@ -11671,7 +10941,7 @@
                 </a:solidFill>
                 <a:latin typeface="Segoe UI"/>
               </a:rPr>
-              <a:t>Entradas del job (cont.)</a:t>
+              <a:t>Entradas del job</a:t>
             </a:r>
             <a:endParaRPr sz="1300" lang="es-ES"/>
           </a:p>
@@ -11679,15 +10949,15 @@
       </p:sp>
       <p:graphicFrame>
         <p:nvGraphicFramePr>
-          <p:cNvPr name="Table 9" id="9"/>
+          <p:cNvPr name="Table 10" id="10"/>
           <p:cNvGraphicFramePr>
             <a:graphicFrameLocks noGrp="true"/>
           </p:cNvGraphicFramePr>
           <p:nvPr/>
         </p:nvGraphicFramePr>
         <p:xfrm>
-          <a:off x="508000" y="1295400"/>
-          <a:ext cx="9448800" cy="3566160"/>
+          <a:off x="508000" y="1657858"/>
+          <a:ext cx="9448800" cy="4462272"/>
         </p:xfrm>
         <a:graphic>
           <a:graphicData uri="http://schemas.openxmlformats.org/drawingml/2006/table">
@@ -11869,6 +11139,516 @@
                   </a:tcPr>
                 </a:tc>
               </a:tr>
+              <a:tr h="298704">
+                <a:tc>
+                  <a:txBody>
+                    <a:bodyPr anchor="t" rtlCol="false"/>
+                    <a:lstStyle/>
+                    <a:p>
+                      <a:pPr algn="r"/>
+                      <a:r>
+                        <a:rPr lang="es-ES" sz="1100" b="false" i="false">
+                          <a:solidFill>
+                            <a:srgbClr val="1F2933"/>
+                          </a:solidFill>
+                          <a:latin typeface="Segoe UI"/>
+                        </a:rPr>
+                        <a:t>1</a:t>
+                      </a:r>
+                      <a:endParaRPr sz="1100" lang="es-ES"/>
+                    </a:p>
+                  </a:txBody>
+                  <a:tcPr marL="76200" marR="76200" marT="38100" marB="38100" anchor="ctr">
+                    <a:lnL>
+                      <a:noFill/>
+                    </a:lnL>
+                    <a:lnR>
+                      <a:noFill/>
+                    </a:lnR>
+                    <a:lnT>
+                      <a:noFill/>
+                    </a:lnT>
+                    <a:lnB cmpd="sng" algn="ctr" cap="flat" w="9525">
+                      <a:solidFill>
+                        <a:srgbClr val="D9DEE5"/>
+                      </a:solidFill>
+                      <a:prstDash val="solid"/>
+                      <a:round/>
+                      <a:headEnd type="none" w="med" len="med"/>
+                      <a:tailEnd type="none" w="med" len="med"/>
+                    </a:lnB>
+                    <a:solidFill>
+                      <a:srgbClr val="FFFFFF"/>
+                    </a:solidFill>
+                  </a:tcPr>
+                </a:tc>
+                <a:tc>
+                  <a:txBody>
+                    <a:bodyPr anchor="t" rtlCol="false"/>
+                    <a:lstStyle/>
+                    <a:p>
+                      <a:pPr algn="l"/>
+                      <a:r>
+                        <a:rPr lang="es-ES" sz="1100" b="false" i="false">
+                          <a:solidFill>
+                            <a:srgbClr val="1F2933"/>
+                          </a:solidFill>
+                          <a:latin typeface="Segoe UI"/>
+                        </a:rPr>
+                        <a:t>START</a:t>
+                      </a:r>
+                      <a:endParaRPr sz="1100" lang="es-ES"/>
+                    </a:p>
+                  </a:txBody>
+                  <a:tcPr marL="76200" marR="76200" marT="38100" marB="38100" anchor="ctr">
+                    <a:lnL>
+                      <a:noFill/>
+                    </a:lnL>
+                    <a:lnR>
+                      <a:noFill/>
+                    </a:lnR>
+                    <a:lnT>
+                      <a:noFill/>
+                    </a:lnT>
+                    <a:lnB cmpd="sng" algn="ctr" cap="flat" w="9525">
+                      <a:solidFill>
+                        <a:srgbClr val="D9DEE5"/>
+                      </a:solidFill>
+                      <a:prstDash val="solid"/>
+                      <a:round/>
+                      <a:headEnd type="none" w="med" len="med"/>
+                      <a:tailEnd type="none" w="med" len="med"/>
+                    </a:lnB>
+                    <a:solidFill>
+                      <a:srgbClr val="FFFFFF"/>
+                    </a:solidFill>
+                  </a:tcPr>
+                </a:tc>
+                <a:tc>
+                  <a:txBody>
+                    <a:bodyPr anchor="t" rtlCol="false"/>
+                    <a:lstStyle/>
+                    <a:p>
+                      <a:pPr algn="l"/>
+                      <a:r>
+                        <a:rPr lang="es-ES" sz="1100" b="false" i="false">
+                          <a:solidFill>
+                            <a:srgbClr val="1F2933"/>
+                          </a:solidFill>
+                          <a:latin typeface="Segoe UI"/>
+                        </a:rPr>
+                        <a:t>Inicio (SPECIAL)</a:t>
+                      </a:r>
+                      <a:endParaRPr sz="1100" lang="es-ES"/>
+                    </a:p>
+                  </a:txBody>
+                  <a:tcPr marL="76200" marR="76200" marT="38100" marB="38100" anchor="ctr">
+                    <a:lnL>
+                      <a:noFill/>
+                    </a:lnL>
+                    <a:lnR>
+                      <a:noFill/>
+                    </a:lnR>
+                    <a:lnT>
+                      <a:noFill/>
+                    </a:lnT>
+                    <a:lnB cmpd="sng" algn="ctr" cap="flat" w="9525">
+                      <a:solidFill>
+                        <a:srgbClr val="D9DEE5"/>
+                      </a:solidFill>
+                      <a:prstDash val="solid"/>
+                      <a:round/>
+                      <a:headEnd type="none" w="med" len="med"/>
+                      <a:tailEnd type="none" w="med" len="med"/>
+                    </a:lnB>
+                    <a:solidFill>
+                      <a:srgbClr val="FFFFFF"/>
+                    </a:solidFill>
+                  </a:tcPr>
+                </a:tc>
+                <a:tc>
+                  <a:txBody>
+                    <a:bodyPr anchor="t" rtlCol="false"/>
+                    <a:lstStyle/>
+                    <a:p>
+                      <a:pPr algn="l"/>
+                      <a:r>
+                        <a:rPr lang="es-ES" sz="1100" b="false" i="false">
+                          <a:solidFill>
+                            <a:srgbClr val="1F2933"/>
+                          </a:solidFill>
+                          <a:latin typeface="Segoe UI"/>
+                        </a:rPr>
+                        <a:t>Inicio del job</a:t>
+                      </a:r>
+                      <a:endParaRPr sz="1100" lang="es-ES"/>
+                    </a:p>
+                  </a:txBody>
+                  <a:tcPr marL="76200" marR="76200" marT="38100" marB="38100" anchor="ctr">
+                    <a:lnL>
+                      <a:noFill/>
+                    </a:lnL>
+                    <a:lnR>
+                      <a:noFill/>
+                    </a:lnR>
+                    <a:lnT>
+                      <a:noFill/>
+                    </a:lnT>
+                    <a:lnB cmpd="sng" algn="ctr" cap="flat" w="9525">
+                      <a:solidFill>
+                        <a:srgbClr val="D9DEE5"/>
+                      </a:solidFill>
+                      <a:prstDash val="solid"/>
+                      <a:round/>
+                      <a:headEnd type="none" w="med" len="med"/>
+                      <a:tailEnd type="none" w="med" len="med"/>
+                    </a:lnB>
+                    <a:solidFill>
+                      <a:srgbClr val="FFFFFF"/>
+                    </a:solidFill>
+                  </a:tcPr>
+                </a:tc>
+              </a:tr>
+              <a:tr h="298704">
+                <a:tc>
+                  <a:txBody>
+                    <a:bodyPr anchor="t" rtlCol="false"/>
+                    <a:lstStyle/>
+                    <a:p>
+                      <a:pPr algn="r"/>
+                      <a:r>
+                        <a:rPr lang="es-ES" sz="1100" b="false" i="false">
+                          <a:solidFill>
+                            <a:srgbClr val="1F2933"/>
+                          </a:solidFill>
+                          <a:latin typeface="Segoe UI"/>
+                        </a:rPr>
+                        <a:t>2</a:t>
+                      </a:r>
+                      <a:endParaRPr sz="1100" lang="es-ES"/>
+                    </a:p>
+                  </a:txBody>
+                  <a:tcPr marL="76200" marR="76200" marT="38100" marB="38100" anchor="ctr">
+                    <a:lnL>
+                      <a:noFill/>
+                    </a:lnL>
+                    <a:lnR>
+                      <a:noFill/>
+                    </a:lnR>
+                    <a:lnT>
+                      <a:noFill/>
+                    </a:lnT>
+                    <a:lnB cmpd="sng" algn="ctr" cap="flat" w="9525">
+                      <a:solidFill>
+                        <a:srgbClr val="D9DEE5"/>
+                      </a:solidFill>
+                      <a:prstDash val="solid"/>
+                      <a:round/>
+                      <a:headEnd type="none" w="med" len="med"/>
+                      <a:tailEnd type="none" w="med" len="med"/>
+                    </a:lnB>
+                    <a:solidFill>
+                      <a:srgbClr val="F0F1F3"/>
+                    </a:solidFill>
+                  </a:tcPr>
+                </a:tc>
+                <a:tc>
+                  <a:txBody>
+                    <a:bodyPr anchor="t" rtlCol="false"/>
+                    <a:lstStyle/>
+                    <a:p>
+                      <a:pPr algn="l"/>
+                      <a:r>
+                        <a:rPr lang="es-ES" sz="1100" b="false" i="false">
+                          <a:solidFill>
+                            <a:srgbClr val="1F2933"/>
+                          </a:solidFill>
+                          <a:latin typeface="Segoe UI"/>
+                        </a:rPr>
+                        <a:t>Comprobar ficheros de entrada</a:t>
+                      </a:r>
+                      <a:endParaRPr sz="1100" lang="es-ES"/>
+                    </a:p>
+                  </a:txBody>
+                  <a:tcPr marL="76200" marR="76200" marT="38100" marB="38100" anchor="ctr">
+                    <a:lnL>
+                      <a:noFill/>
+                    </a:lnL>
+                    <a:lnR>
+                      <a:noFill/>
+                    </a:lnR>
+                    <a:lnT>
+                      <a:noFill/>
+                    </a:lnT>
+                    <a:lnB cmpd="sng" algn="ctr" cap="flat" w="9525">
+                      <a:solidFill>
+                        <a:srgbClr val="D9DEE5"/>
+                      </a:solidFill>
+                      <a:prstDash val="solid"/>
+                      <a:round/>
+                      <a:headEnd type="none" w="med" len="med"/>
+                      <a:tailEnd type="none" w="med" len="med"/>
+                    </a:lnB>
+                    <a:solidFill>
+                      <a:srgbClr val="F0F1F3"/>
+                    </a:solidFill>
+                  </a:tcPr>
+                </a:tc>
+                <a:tc>
+                  <a:txBody>
+                    <a:bodyPr anchor="t" rtlCol="false"/>
+                    <a:lstStyle/>
+                    <a:p>
+                      <a:pPr algn="l"/>
+                      <a:r>
+                        <a:rPr lang="es-ES" sz="1100" b="false" i="false">
+                          <a:solidFill>
+                            <a:srgbClr val="1F2933"/>
+                          </a:solidFill>
+                          <a:latin typeface="Segoe UI"/>
+                        </a:rPr>
+                        <a:t>Los archivos existen (FILES_EXIST)</a:t>
+                      </a:r>
+                      <a:endParaRPr sz="1100" lang="es-ES"/>
+                    </a:p>
+                  </a:txBody>
+                  <a:tcPr marL="76200" marR="76200" marT="38100" marB="38100" anchor="ctr">
+                    <a:lnL>
+                      <a:noFill/>
+                    </a:lnL>
+                    <a:lnR>
+                      <a:noFill/>
+                    </a:lnR>
+                    <a:lnT>
+                      <a:noFill/>
+                    </a:lnT>
+                    <a:lnB cmpd="sng" algn="ctr" cap="flat" w="9525">
+                      <a:solidFill>
+                        <a:srgbClr val="D9DEE5"/>
+                      </a:solidFill>
+                      <a:prstDash val="solid"/>
+                      <a:round/>
+                      <a:headEnd type="none" w="med" len="med"/>
+                      <a:tailEnd type="none" w="med" len="med"/>
+                    </a:lnB>
+                    <a:solidFill>
+                      <a:srgbClr val="F0F1F3"/>
+                    </a:solidFill>
+                  </a:tcPr>
+                </a:tc>
+                <a:tc>
+                  <a:txBody>
+                    <a:bodyPr anchor="t" rtlCol="false"/>
+                    <a:lstStyle/>
+                    <a:p>
+                      <a:pPr algn="l"/>
+                      <a:r>
+                        <a:rPr lang="es-ES" sz="1100" b="false" i="false">
+                          <a:solidFill>
+                            <a:srgbClr val="1F2933"/>
+                          </a:solidFill>
+                          <a:latin typeface="Segoe UI"/>
+                        </a:rPr>
+                        <a:t>Los archivos existen</a:t>
+                      </a:r>
+                      <a:endParaRPr sz="1100" lang="es-ES"/>
+                    </a:p>
+                  </a:txBody>
+                  <a:tcPr marL="76200" marR="76200" marT="38100" marB="38100" anchor="ctr">
+                    <a:lnL>
+                      <a:noFill/>
+                    </a:lnL>
+                    <a:lnR>
+                      <a:noFill/>
+                    </a:lnR>
+                    <a:lnT>
+                      <a:noFill/>
+                    </a:lnT>
+                    <a:lnB cmpd="sng" algn="ctr" cap="flat" w="9525">
+                      <a:solidFill>
+                        <a:srgbClr val="D9DEE5"/>
+                      </a:solidFill>
+                      <a:prstDash val="solid"/>
+                      <a:round/>
+                      <a:headEnd type="none" w="med" len="med"/>
+                      <a:tailEnd type="none" w="med" len="med"/>
+                    </a:lnB>
+                    <a:solidFill>
+                      <a:srgbClr val="F0F1F3"/>
+                    </a:solidFill>
+                  </a:tcPr>
+                </a:tc>
+              </a:tr>
+              <a:tr h="298704">
+                <a:tc>
+                  <a:txBody>
+                    <a:bodyPr anchor="t" rtlCol="false"/>
+                    <a:lstStyle/>
+                    <a:p>
+                      <a:pPr algn="r"/>
+                      <a:r>
+                        <a:rPr lang="es-ES" sz="1100" b="false" i="false">
+                          <a:solidFill>
+                            <a:srgbClr val="1F2933"/>
+                          </a:solidFill>
+                          <a:latin typeface="Segoe UI"/>
+                        </a:rPr>
+                        <a:t>3</a:t>
+                      </a:r>
+                      <a:endParaRPr sz="1100" lang="es-ES"/>
+                    </a:p>
+                  </a:txBody>
+                  <a:tcPr marL="76200" marR="76200" marT="38100" marB="38100" anchor="ctr">
+                    <a:lnL>
+                      <a:noFill/>
+                    </a:lnL>
+                    <a:lnR>
+                      <a:noFill/>
+                    </a:lnR>
+                    <a:lnT>
+                      <a:noFill/>
+                    </a:lnT>
+                    <a:lnB cmpd="sng" algn="ctr" cap="flat" w="9525">
+                      <a:solidFill>
+                        <a:srgbClr val="D9DEE5"/>
+                      </a:solidFill>
+                      <a:prstDash val="solid"/>
+                      <a:round/>
+                      <a:headEnd type="none" w="med" len="med"/>
+                      <a:tailEnd type="none" w="med" len="med"/>
+                    </a:lnB>
+                    <a:solidFill>
+                      <a:srgbClr val="FFFFFF"/>
+                    </a:solidFill>
+                  </a:tcPr>
+                </a:tc>
+                <a:tc>
+                  <a:txBody>
+                    <a:bodyPr anchor="t" rtlCol="false"/>
+                    <a:lstStyle/>
+                    <a:p>
+                      <a:pPr algn="l"/>
+                      <a:r>
+                        <a:rPr lang="es-ES" sz="1100" b="false" i="false">
+                          <a:solidFill>
+                            <a:srgbClr val="1F2933"/>
+                          </a:solidFill>
+                          <a:latin typeface="Segoe UI"/>
+                        </a:rPr>
+                        <a:t>Crear carpeta salida</a:t>
+                      </a:r>
+                      <a:endParaRPr sz="1100" lang="es-ES"/>
+                    </a:p>
+                  </a:txBody>
+                  <a:tcPr marL="76200" marR="76200" marT="38100" marB="38100" anchor="ctr">
+                    <a:lnL>
+                      <a:noFill/>
+                    </a:lnL>
+                    <a:lnR>
+                      <a:noFill/>
+                    </a:lnR>
+                    <a:lnT>
+                      <a:noFill/>
+                    </a:lnT>
+                    <a:lnB cmpd="sng" algn="ctr" cap="flat" w="9525">
+                      <a:solidFill>
+                        <a:srgbClr val="D9DEE5"/>
+                      </a:solidFill>
+                      <a:prstDash val="solid"/>
+                      <a:round/>
+                      <a:headEnd type="none" w="med" len="med"/>
+                      <a:tailEnd type="none" w="med" len="med"/>
+                    </a:lnB>
+                    <a:solidFill>
+                      <a:srgbClr val="FFFFFF"/>
+                    </a:solidFill>
+                  </a:tcPr>
+                </a:tc>
+                <a:tc>
+                  <a:txBody>
+                    <a:bodyPr anchor="t" rtlCol="false"/>
+                    <a:lstStyle/>
+                    <a:p>
+                      <a:pPr algn="l"/>
+                      <a:r>
+                        <a:rPr lang="es-ES" sz="1100" b="false" i="false">
+                          <a:solidFill>
+                            <a:srgbClr val="1F2933"/>
+                          </a:solidFill>
+                          <a:latin typeface="Segoe UI"/>
+                        </a:rPr>
+                        <a:t>Crear carpeta (CREATE_FOLDER)</a:t>
+                      </a:r>
+                      <a:endParaRPr sz="1100" lang="es-ES"/>
+                    </a:p>
+                  </a:txBody>
+                  <a:tcPr marL="76200" marR="76200" marT="38100" marB="38100" anchor="ctr">
+                    <a:lnL>
+                      <a:noFill/>
+                    </a:lnL>
+                    <a:lnR>
+                      <a:noFill/>
+                    </a:lnR>
+                    <a:lnT>
+                      <a:noFill/>
+                    </a:lnT>
+                    <a:lnB cmpd="sng" algn="ctr" cap="flat" w="9525">
+                      <a:solidFill>
+                        <a:srgbClr val="D9DEE5"/>
+                      </a:solidFill>
+                      <a:prstDash val="solid"/>
+                      <a:round/>
+                      <a:headEnd type="none" w="med" len="med"/>
+                      <a:tailEnd type="none" w="med" len="med"/>
+                    </a:lnB>
+                    <a:solidFill>
+                      <a:srgbClr val="FFFFFF"/>
+                    </a:solidFill>
+                  </a:tcPr>
+                </a:tc>
+                <a:tc>
+                  <a:txBody>
+                    <a:bodyPr anchor="t" rtlCol="false"/>
+                    <a:lstStyle/>
+                    <a:p>
+                      <a:pPr algn="l"/>
+                      <a:r>
+                        <a:rPr lang="es-ES" sz="1100" b="false" i="false">
+                          <a:solidFill>
+                            <a:srgbClr val="1F2933"/>
+                          </a:solidFill>
+                          <a:latin typeface="Segoe UI"/>
+                        </a:rPr>
+                        <a:t>Crear carpeta</a:t>
+                      </a:r>
+                      <a:endParaRPr sz="1100" lang="es-ES"/>
+                    </a:p>
+                  </a:txBody>
+                  <a:tcPr marL="76200" marR="76200" marT="38100" marB="38100" anchor="ctr">
+                    <a:lnL>
+                      <a:noFill/>
+                    </a:lnL>
+                    <a:lnR>
+                      <a:noFill/>
+                    </a:lnR>
+                    <a:lnT>
+                      <a:noFill/>
+                    </a:lnT>
+                    <a:lnB cmpd="sng" algn="ctr" cap="flat" w="9525">
+                      <a:solidFill>
+                        <a:srgbClr val="D9DEE5"/>
+                      </a:solidFill>
+                      <a:prstDash val="solid"/>
+                      <a:round/>
+                      <a:headEnd type="none" w="med" len="med"/>
+                      <a:tailEnd type="none" w="med" len="med"/>
+                    </a:lnB>
+                    <a:solidFill>
+                      <a:srgbClr val="FFFFFF"/>
+                    </a:solidFill>
+                  </a:tcPr>
+                </a:tc>
+              </a:tr>
               <a:tr h="851916">
                 <a:tc>
                   <a:txBody>
@@ -11908,7 +11688,7 @@
                       <a:tailEnd type="none" w="med" len="med"/>
                     </a:lnB>
                     <a:solidFill>
-                      <a:srgbClr val="FFFFFF"/>
+                      <a:srgbClr val="F0F1F3"/>
                     </a:solidFill>
                   </a:tcPr>
                 </a:tc>
@@ -11950,7 +11730,7 @@
                       <a:tailEnd type="none" w="med" len="med"/>
                     </a:lnB>
                     <a:solidFill>
-                      <a:srgbClr val="FFFFFF"/>
+                      <a:srgbClr val="F0F1F3"/>
                     </a:solidFill>
                   </a:tcPr>
                 </a:tc>
@@ -11992,7 +11772,7 @@
                       <a:tailEnd type="none" w="med" len="med"/>
                     </a:lnB>
                     <a:solidFill>
-                      <a:srgbClr val="FFFFFF"/>
+                      <a:srgbClr val="F0F1F3"/>
                     </a:solidFill>
                   </a:tcPr>
                 </a:tc>
@@ -12034,7 +11814,7 @@
                       <a:tailEnd type="none" w="med" len="med"/>
                     </a:lnB>
                     <a:solidFill>
-                      <a:srgbClr val="FFFFFF"/>
+                      <a:srgbClr val="F0F1F3"/>
                     </a:solidFill>
                   </a:tcPr>
                 </a:tc>
@@ -12078,7 +11858,7 @@
                       <a:tailEnd type="none" w="med" len="med"/>
                     </a:lnB>
                     <a:solidFill>
-                      <a:srgbClr val="F0F1F3"/>
+                      <a:srgbClr val="FFFFFF"/>
                     </a:solidFill>
                   </a:tcPr>
                 </a:tc>
@@ -12120,7 +11900,7 @@
                       <a:tailEnd type="none" w="med" len="med"/>
                     </a:lnB>
                     <a:solidFill>
-                      <a:srgbClr val="F0F1F3"/>
+                      <a:srgbClr val="FFFFFF"/>
                     </a:solidFill>
                   </a:tcPr>
                 </a:tc>
@@ -12162,7 +11942,7 @@
                       <a:tailEnd type="none" w="med" len="med"/>
                     </a:lnB>
                     <a:solidFill>
-                      <a:srgbClr val="F0F1F3"/>
+                      <a:srgbClr val="FFFFFF"/>
                     </a:solidFill>
                   </a:tcPr>
                 </a:tc>
@@ -12204,7 +11984,7 @@
                       <a:tailEnd type="none" w="med" len="med"/>
                     </a:lnB>
                     <a:solidFill>
-                      <a:srgbClr val="F0F1F3"/>
+                      <a:srgbClr val="FFFFFF"/>
                     </a:solidFill>
                   </a:tcPr>
                 </a:tc>
@@ -12248,7 +12028,7 @@
                       <a:tailEnd type="none" w="med" len="med"/>
                     </a:lnB>
                     <a:solidFill>
-                      <a:srgbClr val="FFFFFF"/>
+                      <a:srgbClr val="F0F1F3"/>
                     </a:solidFill>
                   </a:tcPr>
                 </a:tc>
@@ -12290,7 +12070,7 @@
                       <a:tailEnd type="none" w="med" len="med"/>
                     </a:lnB>
                     <a:solidFill>
-                      <a:srgbClr val="FFFFFF"/>
+                      <a:srgbClr val="F0F1F3"/>
                     </a:solidFill>
                   </a:tcPr>
                 </a:tc>
@@ -12332,7 +12112,7 @@
                       <a:tailEnd type="none" w="med" len="med"/>
                     </a:lnB>
                     <a:solidFill>
-                      <a:srgbClr val="FFFFFF"/>
+                      <a:srgbClr val="F0F1F3"/>
                     </a:solidFill>
                   </a:tcPr>
                 </a:tc>
@@ -12374,7 +12154,7 @@
                       <a:tailEnd type="none" w="med" len="med"/>
                     </a:lnB>
                     <a:solidFill>
-                      <a:srgbClr val="FFFFFF"/>
+                      <a:srgbClr val="F0F1F3"/>
                     </a:solidFill>
                   </a:tcPr>
                 </a:tc>
@@ -12418,7 +12198,7 @@
                       <a:tailEnd type="none" w="med" len="med"/>
                     </a:lnB>
                     <a:solidFill>
-                      <a:srgbClr val="F0F1F3"/>
+                      <a:srgbClr val="FFFFFF"/>
                     </a:solidFill>
                   </a:tcPr>
                 </a:tc>
@@ -12460,7 +12240,7 @@
                       <a:tailEnd type="none" w="med" len="med"/>
                     </a:lnB>
                     <a:solidFill>
-                      <a:srgbClr val="F0F1F3"/>
+                      <a:srgbClr val="FFFFFF"/>
                     </a:solidFill>
                   </a:tcPr>
                 </a:tc>
@@ -12502,7 +12282,7 @@
                       <a:tailEnd type="none" w="med" len="med"/>
                     </a:lnB>
                     <a:solidFill>
-                      <a:srgbClr val="F0F1F3"/>
+                      <a:srgbClr val="FFFFFF"/>
                     </a:solidFill>
                   </a:tcPr>
                 </a:tc>
@@ -12544,7 +12324,7 @@
                       <a:tailEnd type="none" w="med" len="med"/>
                     </a:lnB>
                     <a:solidFill>
-                      <a:srgbClr val="F0F1F3"/>
+                      <a:srgbClr val="FFFFFF"/>
                     </a:solidFill>
                   </a:tcPr>
                 </a:tc>
@@ -12588,7 +12368,7 @@
                       <a:tailEnd type="none" w="med" len="med"/>
                     </a:lnB>
                     <a:solidFill>
-                      <a:srgbClr val="FFFFFF"/>
+                      <a:srgbClr val="F0F1F3"/>
                     </a:solidFill>
                   </a:tcPr>
                 </a:tc>
@@ -12630,7 +12410,7 @@
                       <a:tailEnd type="none" w="med" len="med"/>
                     </a:lnB>
                     <a:solidFill>
-                      <a:srgbClr val="FFFFFF"/>
+                      <a:srgbClr val="F0F1F3"/>
                     </a:solidFill>
                   </a:tcPr>
                 </a:tc>
@@ -12672,7 +12452,7 @@
                       <a:tailEnd type="none" w="med" len="med"/>
                     </a:lnB>
                     <a:solidFill>
-                      <a:srgbClr val="FFFFFF"/>
+                      <a:srgbClr val="F0F1F3"/>
                     </a:solidFill>
                   </a:tcPr>
                 </a:tc>
@@ -12714,7 +12494,7 @@
                       <a:tailEnd type="none" w="med" len="med"/>
                     </a:lnB>
                     <a:solidFill>
-                      <a:srgbClr val="FFFFFF"/>
+                      <a:srgbClr val="F0F1F3"/>
                     </a:solidFill>
                   </a:tcPr>
                 </a:tc>
@@ -12758,7 +12538,7 @@
                       <a:tailEnd type="none" w="med" len="med"/>
                     </a:lnB>
                     <a:solidFill>
-                      <a:srgbClr val="F0F1F3"/>
+                      <a:srgbClr val="FFFFFF"/>
                     </a:solidFill>
                   </a:tcPr>
                 </a:tc>
@@ -12800,7 +12580,7 @@
                       <a:tailEnd type="none" w="med" len="med"/>
                     </a:lnB>
                     <a:solidFill>
-                      <a:srgbClr val="F0F1F3"/>
+                      <a:srgbClr val="FFFFFF"/>
                     </a:solidFill>
                   </a:tcPr>
                 </a:tc>
@@ -12842,7 +12622,7 @@
                       <a:tailEnd type="none" w="med" len="med"/>
                     </a:lnB>
                     <a:solidFill>
-                      <a:srgbClr val="F0F1F3"/>
+                      <a:srgbClr val="FFFFFF"/>
                     </a:solidFill>
                   </a:tcPr>
                 </a:tc>
@@ -12884,7 +12664,7 @@
                       <a:tailEnd type="none" w="med" len="med"/>
                     </a:lnB>
                     <a:solidFill>
-                      <a:srgbClr val="F0F1F3"/>
+                      <a:srgbClr val="FFFFFF"/>
                     </a:solidFill>
                   </a:tcPr>
                 </a:tc>
@@ -13075,7 +12855,7 @@
           <a:lstStyle/>
           <a:p>
             <a:pPr algn="r"/>
-            <a:fld id="{095E69B8-FB87-47B5-A275-D98E227303DF}" type="slidenum">
+            <a:fld id="{7F8B81B9-D9AE-4F06-A217-C3A510972E13}" type="slidenum">
               <a:rPr lang="es-ES" sz="750">
                 <a:solidFill>
                   <a:srgbClr val="6B7785"/>
@@ -15088,7 +14868,7 @@
           <a:lstStyle/>
           <a:p>
             <a:pPr algn="r"/>
-            <a:fld id="{90A5F638-E7E4-4F32-A3B6-5B6684B0A5ED}" type="slidenum">
+            <a:fld id="{27E003DD-69F5-4A19-ABBB-ADB897CD393C}" type="slidenum">
               <a:rPr lang="es-ES" sz="750">
                 <a:solidFill>
                   <a:srgbClr val="6B7785"/>
@@ -15187,7 +14967,7 @@
                 </a:solidFill>
                 <a:latin typeface="Segoe UI"/>
               </a:rPr>
-              <a:t>3,4 s</a:t>
+              <a:t>3,2 s</a:t>
             </a:r>
             <a:endParaRPr sz="2200" lang="es-ES"/>
           </a:p>
@@ -15384,7 +15164,7 @@
                 </a:solidFill>
                 <a:latin typeface="Segoe UI"/>
               </a:rPr>
-              <a:t>10</a:t>
+              <a:t>9</a:t>
             </a:r>
             <a:endParaRPr sz="2200" lang="es-ES"/>
           </a:p>
@@ -15581,7 +15361,7 @@
                 </a:solidFill>
                 <a:latin typeface="Segoe UI"/>
               </a:rPr>
-              <a:t>1,0 s</a:t>
+              <a:t>839 ms</a:t>
             </a:r>
             <a:endParaRPr sz="900" lang="es-ES"/>
           </a:p>
@@ -15824,7 +15604,7 @@
           <a:lstStyle/>
           <a:p>
             <a:pPr algn="r"/>
-            <a:fld id="{8937C109-64D8-431F-9C3C-562F3F2B06AD}" type="slidenum">
+            <a:fld id="{D8C6848C-C762-426D-9658-085CA3268978}" type="slidenum">
               <a:rPr lang="es-ES" sz="750">
                 <a:solidFill>
                   <a:srgbClr val="6B7785"/>
@@ -15896,7 +15676,7 @@
         <p:spPr>
           <a:xfrm>
             <a:off x="508000" y="1295400"/>
-            <a:ext cx="11176000" cy="3492500"/>
+            <a:ext cx="11176000" cy="3213100"/>
           </a:xfrm>
           <a:prstGeom prst="rect">
             <a:avLst/>
@@ -15911,7 +15691,7 @@
         </p:nvSpPr>
         <p:spPr>
           <a:xfrm>
-            <a:off x="508000" y="4838700"/>
+            <a:off x="508000" y="4559300"/>
             <a:ext cx="11176000" cy="235458"/>
           </a:xfrm>
           <a:prstGeom prst="rect">

</xml_diff>